<commit_message>
[FHIR-57202](https://jira.hl7.org/browse/FHIR-57202): default profiles for Data Exchange
</commit_message>
<xml_diff>
--- a/input/images/source/DEQM Resource Diagram.pptx
+++ b/input/images/source/DEQM Resource Diagram.pptx
@@ -4,9 +4,12 @@
   <p:sldMasterIdLst>
     <p:sldMasterId id="2147483648" r:id="rId1"/>
   </p:sldMasterIdLst>
+  <p:notesMasterIdLst>
+    <p:notesMasterId r:id="rId4"/>
+  </p:notesMasterIdLst>
   <p:sldIdLst>
     <p:sldId id="256" r:id="rId2"/>
-    <p:sldId id="257" r:id="rId3"/>
+    <p:sldId id="258" r:id="rId3"/>
   </p:sldIdLst>
   <p:sldSz cx="9144000" cy="6858000" type="screen4x3"/>
   <p:notesSz cx="6858000" cy="9144000"/>
@@ -124,6 +127,512 @@
 </p:presentation>
 </file>
 
+<file path=ppt/notesMasters/notesMaster1.xml><?xml version="1.0" encoding="utf-8"?>
+<p:notesMaster xmlns:a="http://schemas.openxmlformats.org/drawingml/2006/main" xmlns:r="http://schemas.openxmlformats.org/officeDocument/2006/relationships" xmlns:p="http://schemas.openxmlformats.org/presentationml/2006/main">
+  <p:cSld>
+    <p:bg>
+      <p:bgRef idx="1001">
+        <a:schemeClr val="bg1"/>
+      </p:bgRef>
+    </p:bg>
+    <p:spTree>
+      <p:nvGrpSpPr>
+        <p:cNvPr id="1" name=""/>
+        <p:cNvGrpSpPr/>
+        <p:nvPr/>
+      </p:nvGrpSpPr>
+      <p:grpSpPr>
+        <a:xfrm>
+          <a:off x="0" y="0"/>
+          <a:ext cx="0" cy="0"/>
+          <a:chOff x="0" y="0"/>
+          <a:chExt cx="0" cy="0"/>
+        </a:xfrm>
+      </p:grpSpPr>
+      <p:sp>
+        <p:nvSpPr>
+          <p:cNvPr id="2" name="Header Placeholder 1"/>
+          <p:cNvSpPr>
+            <a:spLocks noGrp="1"/>
+          </p:cNvSpPr>
+          <p:nvPr>
+            <p:ph type="hdr" sz="quarter"/>
+          </p:nvPr>
+        </p:nvSpPr>
+        <p:spPr>
+          <a:xfrm>
+            <a:off x="0" y="0"/>
+            <a:ext cx="2971800" cy="458788"/>
+          </a:xfrm>
+          <a:prstGeom prst="rect">
+            <a:avLst/>
+          </a:prstGeom>
+        </p:spPr>
+        <p:txBody>
+          <a:bodyPr vert="horz" lIns="91440" tIns="45720" rIns="91440" bIns="45720" rtlCol="0"/>
+          <a:lstStyle>
+            <a:lvl1pPr algn="l">
+              <a:defRPr sz="1200"/>
+            </a:lvl1pPr>
+          </a:lstStyle>
+          <a:p>
+            <a:endParaRPr lang="en-US"/>
+          </a:p>
+        </p:txBody>
+      </p:sp>
+      <p:sp>
+        <p:nvSpPr>
+          <p:cNvPr id="3" name="Date Placeholder 2"/>
+          <p:cNvSpPr>
+            <a:spLocks noGrp="1"/>
+          </p:cNvSpPr>
+          <p:nvPr>
+            <p:ph type="dt" idx="1"/>
+          </p:nvPr>
+        </p:nvSpPr>
+        <p:spPr>
+          <a:xfrm>
+            <a:off x="3884613" y="0"/>
+            <a:ext cx="2971800" cy="458788"/>
+          </a:xfrm>
+          <a:prstGeom prst="rect">
+            <a:avLst/>
+          </a:prstGeom>
+        </p:spPr>
+        <p:txBody>
+          <a:bodyPr vert="horz" lIns="91440" tIns="45720" rIns="91440" bIns="45720" rtlCol="0"/>
+          <a:lstStyle>
+            <a:lvl1pPr algn="r">
+              <a:defRPr sz="1200"/>
+            </a:lvl1pPr>
+          </a:lstStyle>
+          <a:p>
+            <a:fld id="{E8805BCA-E4A6-4B66-BA74-1E677B69E923}" type="datetimeFigureOut">
+              <a:rPr lang="en-US" smtClean="0"/>
+              <a:t>6/16/2026</a:t>
+            </a:fld>
+            <a:endParaRPr lang="en-US"/>
+          </a:p>
+        </p:txBody>
+      </p:sp>
+      <p:sp>
+        <p:nvSpPr>
+          <p:cNvPr id="4" name="Slide Image Placeholder 3"/>
+          <p:cNvSpPr>
+            <a:spLocks noGrp="1" noRot="1" noChangeAspect="1"/>
+          </p:cNvSpPr>
+          <p:nvPr>
+            <p:ph type="sldImg" idx="2"/>
+          </p:nvPr>
+        </p:nvSpPr>
+        <p:spPr>
+          <a:xfrm>
+            <a:off x="1371600" y="1143000"/>
+            <a:ext cx="4114800" cy="3086100"/>
+          </a:xfrm>
+          <a:prstGeom prst="rect">
+            <a:avLst/>
+          </a:prstGeom>
+          <a:noFill/>
+          <a:ln w="12700">
+            <a:solidFill>
+              <a:prstClr val="black"/>
+            </a:solidFill>
+          </a:ln>
+        </p:spPr>
+        <p:txBody>
+          <a:bodyPr vert="horz" lIns="91440" tIns="45720" rIns="91440" bIns="45720" rtlCol="0" anchor="ctr"/>
+          <a:lstStyle/>
+          <a:p>
+            <a:endParaRPr lang="en-US"/>
+          </a:p>
+        </p:txBody>
+      </p:sp>
+      <p:sp>
+        <p:nvSpPr>
+          <p:cNvPr id="5" name="Notes Placeholder 4"/>
+          <p:cNvSpPr>
+            <a:spLocks noGrp="1"/>
+          </p:cNvSpPr>
+          <p:nvPr>
+            <p:ph type="body" sz="quarter" idx="3"/>
+          </p:nvPr>
+        </p:nvSpPr>
+        <p:spPr>
+          <a:xfrm>
+            <a:off x="685800" y="4400550"/>
+            <a:ext cx="5486400" cy="3600450"/>
+          </a:xfrm>
+          <a:prstGeom prst="rect">
+            <a:avLst/>
+          </a:prstGeom>
+        </p:spPr>
+        <p:txBody>
+          <a:bodyPr vert="horz" lIns="91440" tIns="45720" rIns="91440" bIns="45720" rtlCol="0"/>
+          <a:lstStyle/>
+          <a:p>
+            <a:pPr lvl="0"/>
+            <a:r>
+              <a:rPr lang="en-US"/>
+              <a:t>Click to edit Master text styles</a:t>
+            </a:r>
+          </a:p>
+          <a:p>
+            <a:pPr lvl="1"/>
+            <a:r>
+              <a:rPr lang="en-US"/>
+              <a:t>Second level</a:t>
+            </a:r>
+          </a:p>
+          <a:p>
+            <a:pPr lvl="2"/>
+            <a:r>
+              <a:rPr lang="en-US"/>
+              <a:t>Third level</a:t>
+            </a:r>
+          </a:p>
+          <a:p>
+            <a:pPr lvl="3"/>
+            <a:r>
+              <a:rPr lang="en-US"/>
+              <a:t>Fourth level</a:t>
+            </a:r>
+          </a:p>
+          <a:p>
+            <a:pPr lvl="4"/>
+            <a:r>
+              <a:rPr lang="en-US"/>
+              <a:t>Fifth level</a:t>
+            </a:r>
+          </a:p>
+        </p:txBody>
+      </p:sp>
+      <p:sp>
+        <p:nvSpPr>
+          <p:cNvPr id="6" name="Footer Placeholder 5"/>
+          <p:cNvSpPr>
+            <a:spLocks noGrp="1"/>
+          </p:cNvSpPr>
+          <p:nvPr>
+            <p:ph type="ftr" sz="quarter" idx="4"/>
+          </p:nvPr>
+        </p:nvSpPr>
+        <p:spPr>
+          <a:xfrm>
+            <a:off x="0" y="8685213"/>
+            <a:ext cx="2971800" cy="458787"/>
+          </a:xfrm>
+          <a:prstGeom prst="rect">
+            <a:avLst/>
+          </a:prstGeom>
+        </p:spPr>
+        <p:txBody>
+          <a:bodyPr vert="horz" lIns="91440" tIns="45720" rIns="91440" bIns="45720" rtlCol="0" anchor="b"/>
+          <a:lstStyle>
+            <a:lvl1pPr algn="l">
+              <a:defRPr sz="1200"/>
+            </a:lvl1pPr>
+          </a:lstStyle>
+          <a:p>
+            <a:endParaRPr lang="en-US"/>
+          </a:p>
+        </p:txBody>
+      </p:sp>
+      <p:sp>
+        <p:nvSpPr>
+          <p:cNvPr id="7" name="Slide Number Placeholder 6"/>
+          <p:cNvSpPr>
+            <a:spLocks noGrp="1"/>
+          </p:cNvSpPr>
+          <p:nvPr>
+            <p:ph type="sldNum" sz="quarter" idx="5"/>
+          </p:nvPr>
+        </p:nvSpPr>
+        <p:spPr>
+          <a:xfrm>
+            <a:off x="3884613" y="8685213"/>
+            <a:ext cx="2971800" cy="458787"/>
+          </a:xfrm>
+          <a:prstGeom prst="rect">
+            <a:avLst/>
+          </a:prstGeom>
+        </p:spPr>
+        <p:txBody>
+          <a:bodyPr vert="horz" lIns="91440" tIns="45720" rIns="91440" bIns="45720" rtlCol="0" anchor="b"/>
+          <a:lstStyle>
+            <a:lvl1pPr algn="r">
+              <a:defRPr sz="1200"/>
+            </a:lvl1pPr>
+          </a:lstStyle>
+          <a:p>
+            <a:fld id="{8EC68C26-8506-4DCD-806A-78974237999D}" type="slidenum">
+              <a:rPr lang="en-US" smtClean="0"/>
+              <a:t>‹#›</a:t>
+            </a:fld>
+            <a:endParaRPr lang="en-US"/>
+          </a:p>
+        </p:txBody>
+      </p:sp>
+    </p:spTree>
+    <p:extLst>
+      <p:ext uri="{BB962C8B-B14F-4D97-AF65-F5344CB8AC3E}">
+        <p14:creationId xmlns:p14="http://schemas.microsoft.com/office/powerpoint/2010/main" val="3300239359"/>
+      </p:ext>
+    </p:extLst>
+  </p:cSld>
+  <p:clrMap bg1="lt1" tx1="dk1" bg2="lt2" tx2="dk2" accent1="accent1" accent2="accent2" accent3="accent3" accent4="accent4" accent5="accent5" accent6="accent6" hlink="hlink" folHlink="folHlink"/>
+  <p:notesStyle>
+    <a:lvl1pPr marL="0" algn="l" defTabSz="914400" rtl="0" eaLnBrk="1" latinLnBrk="0" hangingPunct="1">
+      <a:defRPr sz="1200" kern="1200">
+        <a:solidFill>
+          <a:schemeClr val="tx1"/>
+        </a:solidFill>
+        <a:latin typeface="+mn-lt"/>
+        <a:ea typeface="+mn-ea"/>
+        <a:cs typeface="+mn-cs"/>
+      </a:defRPr>
+    </a:lvl1pPr>
+    <a:lvl2pPr marL="457200" algn="l" defTabSz="914400" rtl="0" eaLnBrk="1" latinLnBrk="0" hangingPunct="1">
+      <a:defRPr sz="1200" kern="1200">
+        <a:solidFill>
+          <a:schemeClr val="tx1"/>
+        </a:solidFill>
+        <a:latin typeface="+mn-lt"/>
+        <a:ea typeface="+mn-ea"/>
+        <a:cs typeface="+mn-cs"/>
+      </a:defRPr>
+    </a:lvl2pPr>
+    <a:lvl3pPr marL="914400" algn="l" defTabSz="914400" rtl="0" eaLnBrk="1" latinLnBrk="0" hangingPunct="1">
+      <a:defRPr sz="1200" kern="1200">
+        <a:solidFill>
+          <a:schemeClr val="tx1"/>
+        </a:solidFill>
+        <a:latin typeface="+mn-lt"/>
+        <a:ea typeface="+mn-ea"/>
+        <a:cs typeface="+mn-cs"/>
+      </a:defRPr>
+    </a:lvl3pPr>
+    <a:lvl4pPr marL="1371600" algn="l" defTabSz="914400" rtl="0" eaLnBrk="1" latinLnBrk="0" hangingPunct="1">
+      <a:defRPr sz="1200" kern="1200">
+        <a:solidFill>
+          <a:schemeClr val="tx1"/>
+        </a:solidFill>
+        <a:latin typeface="+mn-lt"/>
+        <a:ea typeface="+mn-ea"/>
+        <a:cs typeface="+mn-cs"/>
+      </a:defRPr>
+    </a:lvl4pPr>
+    <a:lvl5pPr marL="1828800" algn="l" defTabSz="914400" rtl="0" eaLnBrk="1" latinLnBrk="0" hangingPunct="1">
+      <a:defRPr sz="1200" kern="1200">
+        <a:solidFill>
+          <a:schemeClr val="tx1"/>
+        </a:solidFill>
+        <a:latin typeface="+mn-lt"/>
+        <a:ea typeface="+mn-ea"/>
+        <a:cs typeface="+mn-cs"/>
+      </a:defRPr>
+    </a:lvl5pPr>
+    <a:lvl6pPr marL="2286000" algn="l" defTabSz="914400" rtl="0" eaLnBrk="1" latinLnBrk="0" hangingPunct="1">
+      <a:defRPr sz="1200" kern="1200">
+        <a:solidFill>
+          <a:schemeClr val="tx1"/>
+        </a:solidFill>
+        <a:latin typeface="+mn-lt"/>
+        <a:ea typeface="+mn-ea"/>
+        <a:cs typeface="+mn-cs"/>
+      </a:defRPr>
+    </a:lvl6pPr>
+    <a:lvl7pPr marL="2743200" algn="l" defTabSz="914400" rtl="0" eaLnBrk="1" latinLnBrk="0" hangingPunct="1">
+      <a:defRPr sz="1200" kern="1200">
+        <a:solidFill>
+          <a:schemeClr val="tx1"/>
+        </a:solidFill>
+        <a:latin typeface="+mn-lt"/>
+        <a:ea typeface="+mn-ea"/>
+        <a:cs typeface="+mn-cs"/>
+      </a:defRPr>
+    </a:lvl7pPr>
+    <a:lvl8pPr marL="3200400" algn="l" defTabSz="914400" rtl="0" eaLnBrk="1" latinLnBrk="0" hangingPunct="1">
+      <a:defRPr sz="1200" kern="1200">
+        <a:solidFill>
+          <a:schemeClr val="tx1"/>
+        </a:solidFill>
+        <a:latin typeface="+mn-lt"/>
+        <a:ea typeface="+mn-ea"/>
+        <a:cs typeface="+mn-cs"/>
+      </a:defRPr>
+    </a:lvl8pPr>
+    <a:lvl9pPr marL="3657600" algn="l" defTabSz="914400" rtl="0" eaLnBrk="1" latinLnBrk="0" hangingPunct="1">
+      <a:defRPr sz="1200" kern="1200">
+        <a:solidFill>
+          <a:schemeClr val="tx1"/>
+        </a:solidFill>
+        <a:latin typeface="+mn-lt"/>
+        <a:ea typeface="+mn-ea"/>
+        <a:cs typeface="+mn-cs"/>
+      </a:defRPr>
+    </a:lvl9pPr>
+  </p:notesStyle>
+</p:notesMaster>
+</file>
+
+<file path=ppt/notesSlides/notesSlide1.xml><?xml version="1.0" encoding="utf-8"?>
+<p:notes xmlns:a="http://schemas.openxmlformats.org/drawingml/2006/main" xmlns:r="http://schemas.openxmlformats.org/officeDocument/2006/relationships" xmlns:p="http://schemas.openxmlformats.org/presentationml/2006/main">
+  <p:cSld>
+    <p:spTree>
+      <p:nvGrpSpPr>
+        <p:cNvPr id="1" name=""/>
+        <p:cNvGrpSpPr/>
+        <p:nvPr/>
+      </p:nvGrpSpPr>
+      <p:grpSpPr>
+        <a:xfrm>
+          <a:off x="0" y="0"/>
+          <a:ext cx="0" cy="0"/>
+          <a:chOff x="0" y="0"/>
+          <a:chExt cx="0" cy="0"/>
+        </a:xfrm>
+      </p:grpSpPr>
+      <p:sp>
+        <p:nvSpPr>
+          <p:cNvPr id="2" name="Slide Image Placeholder 1"/>
+          <p:cNvSpPr>
+            <a:spLocks noGrp="1" noRot="1" noChangeAspect="1"/>
+          </p:cNvSpPr>
+          <p:nvPr>
+            <p:ph type="sldImg"/>
+          </p:nvPr>
+        </p:nvSpPr>
+        <p:spPr/>
+        <p:txBody>
+          <a:bodyPr/>
+          <a:lstStyle/>
+          <a:p>
+            <a:endParaRPr lang="en-US"/>
+          </a:p>
+        </p:txBody>
+      </p:sp>
+      <p:sp>
+        <p:nvSpPr>
+          <p:cNvPr id="3" name="Notes Placeholder 2"/>
+          <p:cNvSpPr>
+            <a:spLocks noGrp="1"/>
+          </p:cNvSpPr>
+          <p:nvPr>
+            <p:ph type="body" idx="1"/>
+          </p:nvPr>
+        </p:nvSpPr>
+        <p:spPr/>
+        <p:txBody>
+          <a:bodyPr/>
+          <a:lstStyle/>
+          <a:p>
+            <a:r>
+              <a:rPr lang="en-US" dirty="0"/>
+              <a:t>Updated 6/1/26 for https://jira.hl7.org/browse/FHIR-57202</a:t>
+            </a:r>
+          </a:p>
+          <a:p>
+            <a:endParaRPr lang="en-US" dirty="0"/>
+          </a:p>
+        </p:txBody>
+      </p:sp>
+      <p:sp>
+        <p:nvSpPr>
+          <p:cNvPr id="4" name="Slide Number Placeholder 3"/>
+          <p:cNvSpPr>
+            <a:spLocks noGrp="1"/>
+          </p:cNvSpPr>
+          <p:nvPr>
+            <p:ph type="sldNum" sz="quarter" idx="5"/>
+          </p:nvPr>
+        </p:nvSpPr>
+        <p:spPr/>
+        <p:txBody>
+          <a:bodyPr/>
+          <a:lstStyle/>
+          <a:p>
+            <a:pPr marL="0" marR="0" lvl="0" indent="0" algn="r" defTabSz="914400" rtl="0" eaLnBrk="1" fontAlgn="auto" latinLnBrk="0" hangingPunct="1">
+              <a:lnSpc>
+                <a:spcPct val="100000"/>
+              </a:lnSpc>
+              <a:spcBef>
+                <a:spcPts val="0"/>
+              </a:spcBef>
+              <a:spcAft>
+                <a:spcPts val="0"/>
+              </a:spcAft>
+              <a:buClrTx/>
+              <a:buSzTx/>
+              <a:buFontTx/>
+              <a:buNone/>
+              <a:tabLst/>
+              <a:defRPr/>
+            </a:pPr>
+            <a:fld id="{7E1BCCE4-7F70-4733-B15B-578428F7CB14}" type="slidenum">
+              <a:rPr kumimoji="0" lang="en-US" sz="1200" b="0" i="0" u="none" strike="noStrike" kern="1200" cap="none" spc="0" normalizeH="0" baseline="0" noProof="0" smtClean="0">
+                <a:ln>
+                  <a:noFill/>
+                </a:ln>
+                <a:solidFill>
+                  <a:prstClr val="black"/>
+                </a:solidFill>
+                <a:effectLst/>
+                <a:uLnTx/>
+                <a:uFillTx/>
+                <a:latin typeface="Aptos" panose="02110004020202020204"/>
+                <a:ea typeface="+mn-ea"/>
+                <a:cs typeface="+mn-cs"/>
+              </a:rPr>
+              <a:pPr marL="0" marR="0" lvl="0" indent="0" algn="r" defTabSz="914400" rtl="0" eaLnBrk="1" fontAlgn="auto" latinLnBrk="0" hangingPunct="1">
+                <a:lnSpc>
+                  <a:spcPct val="100000"/>
+                </a:lnSpc>
+                <a:spcBef>
+                  <a:spcPts val="0"/>
+                </a:spcBef>
+                <a:spcAft>
+                  <a:spcPts val="0"/>
+                </a:spcAft>
+                <a:buClrTx/>
+                <a:buSzTx/>
+                <a:buFontTx/>
+                <a:buNone/>
+                <a:tabLst/>
+                <a:defRPr/>
+              </a:pPr>
+              <a:t>2</a:t>
+            </a:fld>
+            <a:endParaRPr kumimoji="0" lang="en-US" sz="1200" b="0" i="0" u="none" strike="noStrike" kern="1200" cap="none" spc="0" normalizeH="0" baseline="0" noProof="0">
+              <a:ln>
+                <a:noFill/>
+              </a:ln>
+              <a:solidFill>
+                <a:prstClr val="black"/>
+              </a:solidFill>
+              <a:effectLst/>
+              <a:uLnTx/>
+              <a:uFillTx/>
+              <a:latin typeface="Aptos" panose="02110004020202020204"/>
+              <a:ea typeface="+mn-ea"/>
+              <a:cs typeface="+mn-cs"/>
+            </a:endParaRPr>
+          </a:p>
+        </p:txBody>
+      </p:sp>
+    </p:spTree>
+    <p:extLst>
+      <p:ext uri="{BB962C8B-B14F-4D97-AF65-F5344CB8AC3E}">
+        <p14:creationId xmlns:p14="http://schemas.microsoft.com/office/powerpoint/2010/main" val="1599691528"/>
+      </p:ext>
+    </p:extLst>
+  </p:cSld>
+  <p:clrMapOvr>
+    <a:masterClrMapping/>
+  </p:clrMapOvr>
+</p:notes>
+</file>
+
 <file path=ppt/slideLayouts/slideLayout1.xml><?xml version="1.0" encoding="utf-8"?>
 <p:sldLayout xmlns:a="http://schemas.openxmlformats.org/drawingml/2006/main" xmlns:r="http://schemas.openxmlformats.org/officeDocument/2006/relationships" xmlns:p="http://schemas.openxmlformats.org/presentationml/2006/main" type="title" preserve="1">
   <p:cSld name="Title Slide">
@@ -303,7 +812,7 @@
           <a:p>
             <a:fld id="{7D2F21E0-95B6-4C5C-A55D-C5056E4C25C4}" type="datetimeFigureOut">
               <a:rPr lang="en-US" smtClean="0"/>
-              <a:t>6/14/20</a:t>
+              <a:t>6/16/2026</a:t>
             </a:fld>
             <a:endParaRPr lang="en-US"/>
           </a:p>
@@ -471,7 +980,7 @@
           <a:p>
             <a:fld id="{7D2F21E0-95B6-4C5C-A55D-C5056E4C25C4}" type="datetimeFigureOut">
               <a:rPr lang="en-US" smtClean="0"/>
-              <a:t>6/14/20</a:t>
+              <a:t>6/16/2026</a:t>
             </a:fld>
             <a:endParaRPr lang="en-US"/>
           </a:p>
@@ -649,7 +1158,7 @@
           <a:p>
             <a:fld id="{7D2F21E0-95B6-4C5C-A55D-C5056E4C25C4}" type="datetimeFigureOut">
               <a:rPr lang="en-US" smtClean="0"/>
-              <a:t>6/14/20</a:t>
+              <a:t>6/16/2026</a:t>
             </a:fld>
             <a:endParaRPr lang="en-US"/>
           </a:p>
@@ -817,7 +1326,7 @@
           <a:p>
             <a:fld id="{7D2F21E0-95B6-4C5C-A55D-C5056E4C25C4}" type="datetimeFigureOut">
               <a:rPr lang="en-US" smtClean="0"/>
-              <a:t>6/14/20</a:t>
+              <a:t>6/16/2026</a:t>
             </a:fld>
             <a:endParaRPr lang="en-US"/>
           </a:p>
@@ -1062,7 +1571,7 @@
           <a:p>
             <a:fld id="{7D2F21E0-95B6-4C5C-A55D-C5056E4C25C4}" type="datetimeFigureOut">
               <a:rPr lang="en-US" smtClean="0"/>
-              <a:t>6/14/20</a:t>
+              <a:t>6/16/2026</a:t>
             </a:fld>
             <a:endParaRPr lang="en-US"/>
           </a:p>
@@ -1347,7 +1856,7 @@
           <a:p>
             <a:fld id="{7D2F21E0-95B6-4C5C-A55D-C5056E4C25C4}" type="datetimeFigureOut">
               <a:rPr lang="en-US" smtClean="0"/>
-              <a:t>6/14/20</a:t>
+              <a:t>6/16/2026</a:t>
             </a:fld>
             <a:endParaRPr lang="en-US"/>
           </a:p>
@@ -1766,7 +2275,7 @@
           <a:p>
             <a:fld id="{7D2F21E0-95B6-4C5C-A55D-C5056E4C25C4}" type="datetimeFigureOut">
               <a:rPr lang="en-US" smtClean="0"/>
-              <a:t>6/14/20</a:t>
+              <a:t>6/16/2026</a:t>
             </a:fld>
             <a:endParaRPr lang="en-US"/>
           </a:p>
@@ -1883,7 +2392,7 @@
           <a:p>
             <a:fld id="{7D2F21E0-95B6-4C5C-A55D-C5056E4C25C4}" type="datetimeFigureOut">
               <a:rPr lang="en-US" smtClean="0"/>
-              <a:t>6/14/20</a:t>
+              <a:t>6/16/2026</a:t>
             </a:fld>
             <a:endParaRPr lang="en-US"/>
           </a:p>
@@ -1978,7 +2487,7 @@
           <a:p>
             <a:fld id="{7D2F21E0-95B6-4C5C-A55D-C5056E4C25C4}" type="datetimeFigureOut">
               <a:rPr lang="en-US" smtClean="0"/>
-              <a:t>6/14/20</a:t>
+              <a:t>6/16/2026</a:t>
             </a:fld>
             <a:endParaRPr lang="en-US"/>
           </a:p>
@@ -2253,7 +2762,7 @@
           <a:p>
             <a:fld id="{7D2F21E0-95B6-4C5C-A55D-C5056E4C25C4}" type="datetimeFigureOut">
               <a:rPr lang="en-US" smtClean="0"/>
-              <a:t>6/14/20</a:t>
+              <a:t>6/16/2026</a:t>
             </a:fld>
             <a:endParaRPr lang="en-US"/>
           </a:p>
@@ -2505,7 +3014,7 @@
           <a:p>
             <a:fld id="{7D2F21E0-95B6-4C5C-A55D-C5056E4C25C4}" type="datetimeFigureOut">
               <a:rPr lang="en-US" smtClean="0"/>
-              <a:t>6/14/20</a:t>
+              <a:t>6/16/2026</a:t>
             </a:fld>
             <a:endParaRPr lang="en-US"/>
           </a:p>
@@ -2716,7 +3225,7 @@
           <a:p>
             <a:fld id="{7D2F21E0-95B6-4C5C-A55D-C5056E4C25C4}" type="datetimeFigureOut">
               <a:rPr lang="en-US" smtClean="0"/>
-              <a:t>6/14/20</a:t>
+              <a:t>6/16/2026</a:t>
             </a:fld>
             <a:endParaRPr lang="en-US"/>
           </a:p>
@@ -3147,7 +3656,13 @@
   <p:cSld>
     <p:spTree>
       <p:nvGrpSpPr>
-        <p:cNvPr id="1" name=""/>
+        <p:cNvPr id="1" name="">
+          <a:extLst>
+            <a:ext uri="{FF2B5EF4-FFF2-40B4-BE49-F238E27FC236}">
+              <a16:creationId xmlns:a16="http://schemas.microsoft.com/office/drawing/2014/main" id="{6C87F4FF-8D24-D7D5-F9E4-FCB6219FF3D8}"/>
+            </a:ext>
+          </a:extLst>
+        </p:cNvPr>
         <p:cNvGrpSpPr/>
         <p:nvPr/>
       </p:nvGrpSpPr>
@@ -3161,7 +3676,13 @@
       </p:grpSpPr>
       <p:sp>
         <p:nvSpPr>
-          <p:cNvPr id="3" name="Content Placeholder 2"/>
+          <p:cNvPr id="3" name="Content Placeholder 2">
+            <a:extLst>
+              <a:ext uri="{FF2B5EF4-FFF2-40B4-BE49-F238E27FC236}">
+                <a16:creationId xmlns:a16="http://schemas.microsoft.com/office/drawing/2014/main" id="{8D44FDB1-BDD3-467F-8656-9EFEC3C0AD7C}"/>
+              </a:ext>
+            </a:extLst>
+          </p:cNvPr>
           <p:cNvSpPr>
             <a:spLocks noGrp="1"/>
           </p:cNvSpPr>
@@ -3186,7 +3707,13 @@
       </p:sp>
       <p:sp>
         <p:nvSpPr>
-          <p:cNvPr id="4" name="Flowchart: Alternate Process 3"/>
+          <p:cNvPr id="4" name="Flowchart: Alternate Process 3">
+            <a:extLst>
+              <a:ext uri="{FF2B5EF4-FFF2-40B4-BE49-F238E27FC236}">
+                <a16:creationId xmlns:a16="http://schemas.microsoft.com/office/drawing/2014/main" id="{E82E5F0D-0DAE-4B5F-4E38-1B264EE607D1}"/>
+              </a:ext>
+            </a:extLst>
+          </p:cNvPr>
           <p:cNvSpPr/>
           <p:nvPr/>
         </p:nvSpPr>
@@ -3224,12 +3751,37 @@
           <a:bodyPr rtlCol="0" anchor="ctr"/>
           <a:lstStyle/>
           <a:p>
-            <a:pPr algn="ctr"/>
-            <a:r>
-              <a:rPr lang="en-US" sz="1400" dirty="0">
+            <a:pPr marL="0" marR="0" lvl="0" indent="0" algn="ctr" defTabSz="914400" rtl="0" eaLnBrk="1" fontAlgn="auto" latinLnBrk="0" hangingPunct="1">
+              <a:lnSpc>
+                <a:spcPct val="100000"/>
+              </a:lnSpc>
+              <a:spcBef>
+                <a:spcPts val="0"/>
+              </a:spcBef>
+              <a:spcAft>
+                <a:spcPts val="0"/>
+              </a:spcAft>
+              <a:buClrTx/>
+              <a:buSzTx/>
+              <a:buFontTx/>
+              <a:buNone/>
+              <a:tabLst/>
+              <a:defRPr/>
+            </a:pPr>
+            <a:r>
+              <a:rPr kumimoji="0" lang="en-US" sz="1400" b="0" i="0" u="none" strike="noStrike" kern="1200" cap="none" spc="0" normalizeH="0" baseline="0" noProof="0" dirty="0">
+                <a:ln>
+                  <a:noFill/>
+                </a:ln>
                 <a:solidFill>
-                  <a:schemeClr val="bg1"/>
+                  <a:prstClr val="white"/>
                 </a:solidFill>
+                <a:effectLst/>
+                <a:uLnTx/>
+                <a:uFillTx/>
+                <a:latin typeface="Calibri"/>
+                <a:ea typeface="+mn-ea"/>
+                <a:cs typeface="+mn-cs"/>
               </a:rPr>
               <a:t>Measure</a:t>
             </a:r>
@@ -3238,7 +3790,13 @@
       </p:sp>
       <p:sp>
         <p:nvSpPr>
-          <p:cNvPr id="6" name="Flowchart: Alternate Process 5"/>
+          <p:cNvPr id="6" name="Flowchart: Alternate Process 5">
+            <a:extLst>
+              <a:ext uri="{FF2B5EF4-FFF2-40B4-BE49-F238E27FC236}">
+                <a16:creationId xmlns:a16="http://schemas.microsoft.com/office/drawing/2014/main" id="{A3D75CC1-123E-702F-7463-4F808AC55BFA}"/>
+              </a:ext>
+            </a:extLst>
+          </p:cNvPr>
           <p:cNvSpPr/>
           <p:nvPr/>
         </p:nvSpPr>
@@ -3276,12 +3834,37 @@
           <a:bodyPr rtlCol="0" anchor="ctr"/>
           <a:lstStyle/>
           <a:p>
-            <a:pPr algn="ctr"/>
-            <a:r>
-              <a:rPr lang="en-US" sz="1400" dirty="0">
+            <a:pPr marL="0" marR="0" lvl="0" indent="0" algn="ctr" defTabSz="914400" rtl="0" eaLnBrk="1" fontAlgn="auto" latinLnBrk="0" hangingPunct="1">
+              <a:lnSpc>
+                <a:spcPct val="100000"/>
+              </a:lnSpc>
+              <a:spcBef>
+                <a:spcPts val="0"/>
+              </a:spcBef>
+              <a:spcAft>
+                <a:spcPts val="0"/>
+              </a:spcAft>
+              <a:buClrTx/>
+              <a:buSzTx/>
+              <a:buFontTx/>
+              <a:buNone/>
+              <a:tabLst/>
+              <a:defRPr/>
+            </a:pPr>
+            <a:r>
+              <a:rPr kumimoji="0" lang="en-US" sz="1400" b="0" i="0" u="none" strike="noStrike" kern="1200" cap="none" spc="0" normalizeH="0" baseline="0" noProof="0" dirty="0">
+                <a:ln>
+                  <a:noFill/>
+                </a:ln>
                 <a:solidFill>
-                  <a:schemeClr val="bg1"/>
+                  <a:prstClr val="white"/>
                 </a:solidFill>
+                <a:effectLst/>
+                <a:uLnTx/>
+                <a:uFillTx/>
+                <a:latin typeface="Calibri"/>
+                <a:ea typeface="+mn-ea"/>
+                <a:cs typeface="+mn-cs"/>
               </a:rPr>
               <a:t>MeasureReport</a:t>
             </a:r>
@@ -3290,7 +3873,13 @@
       </p:sp>
       <p:sp>
         <p:nvSpPr>
-          <p:cNvPr id="10" name="Flowchart: Alternate Process 9"/>
+          <p:cNvPr id="10" name="Flowchart: Alternate Process 9">
+            <a:extLst>
+              <a:ext uri="{FF2B5EF4-FFF2-40B4-BE49-F238E27FC236}">
+                <a16:creationId xmlns:a16="http://schemas.microsoft.com/office/drawing/2014/main" id="{B0971783-3BE5-266F-3E11-CC59652D1FDF}"/>
+              </a:ext>
+            </a:extLst>
+          </p:cNvPr>
           <p:cNvSpPr/>
           <p:nvPr/>
         </p:nvSpPr>
@@ -3328,12 +3917,37 @@
           <a:bodyPr rtlCol="0" anchor="ctr"/>
           <a:lstStyle/>
           <a:p>
-            <a:pPr algn="ctr"/>
-            <a:r>
-              <a:rPr lang="en-US" sz="1400" dirty="0">
+            <a:pPr marL="0" marR="0" lvl="0" indent="0" algn="ctr" defTabSz="914400" rtl="0" eaLnBrk="1" fontAlgn="auto" latinLnBrk="0" hangingPunct="1">
+              <a:lnSpc>
+                <a:spcPct val="100000"/>
+              </a:lnSpc>
+              <a:spcBef>
+                <a:spcPts val="0"/>
+              </a:spcBef>
+              <a:spcAft>
+                <a:spcPts val="0"/>
+              </a:spcAft>
+              <a:buClrTx/>
+              <a:buSzTx/>
+              <a:buFontTx/>
+              <a:buNone/>
+              <a:tabLst/>
+              <a:defRPr/>
+            </a:pPr>
+            <a:r>
+              <a:rPr kumimoji="0" lang="en-US" sz="1400" b="0" i="0" u="none" strike="noStrike" kern="1200" cap="none" spc="0" normalizeH="0" baseline="0" noProof="0" dirty="0">
+                <a:ln>
+                  <a:noFill/>
+                </a:ln>
                 <a:solidFill>
-                  <a:schemeClr val="bg1"/>
+                  <a:prstClr val="white"/>
                 </a:solidFill>
+                <a:effectLst/>
+                <a:uLnTx/>
+                <a:uFillTx/>
+                <a:latin typeface="Calibri"/>
+                <a:ea typeface="+mn-ea"/>
+                <a:cs typeface="+mn-cs"/>
               </a:rPr>
               <a:t>Any Resources</a:t>
             </a:r>
@@ -3342,7 +3956,13 @@
       </p:sp>
       <p:sp>
         <p:nvSpPr>
-          <p:cNvPr id="11" name="Flowchart: Alternate Process 10"/>
+          <p:cNvPr id="11" name="Flowchart: Alternate Process 10">
+            <a:extLst>
+              <a:ext uri="{FF2B5EF4-FFF2-40B4-BE49-F238E27FC236}">
+                <a16:creationId xmlns:a16="http://schemas.microsoft.com/office/drawing/2014/main" id="{017B81DB-A23E-C35C-96B9-C08AC8F19BC7}"/>
+              </a:ext>
+            </a:extLst>
+          </p:cNvPr>
           <p:cNvSpPr/>
           <p:nvPr/>
         </p:nvSpPr>
@@ -3380,12 +4000,37 @@
           <a:bodyPr rtlCol="0" anchor="ctr"/>
           <a:lstStyle/>
           <a:p>
-            <a:pPr algn="ctr"/>
-            <a:r>
-              <a:rPr lang="en-US" sz="1400" dirty="0">
+            <a:pPr marL="0" marR="0" lvl="0" indent="0" algn="ctr" defTabSz="914400" rtl="0" eaLnBrk="1" fontAlgn="auto" latinLnBrk="0" hangingPunct="1">
+              <a:lnSpc>
+                <a:spcPct val="100000"/>
+              </a:lnSpc>
+              <a:spcBef>
+                <a:spcPts val="0"/>
+              </a:spcBef>
+              <a:spcAft>
+                <a:spcPts val="0"/>
+              </a:spcAft>
+              <a:buClrTx/>
+              <a:buSzTx/>
+              <a:buFontTx/>
+              <a:buNone/>
+              <a:tabLst/>
+              <a:defRPr/>
+            </a:pPr>
+            <a:r>
+              <a:rPr kumimoji="0" lang="en-US" sz="1400" b="0" i="0" u="none" strike="noStrike" kern="1200" cap="none" spc="0" normalizeH="0" baseline="0" noProof="0" dirty="0">
+                <a:ln>
+                  <a:noFill/>
+                </a:ln>
                 <a:solidFill>
-                  <a:schemeClr val="bg1"/>
+                  <a:prstClr val="white"/>
                 </a:solidFill>
+                <a:effectLst/>
+                <a:uLnTx/>
+                <a:uFillTx/>
+                <a:latin typeface="Calibri"/>
+                <a:ea typeface="+mn-ea"/>
+                <a:cs typeface="+mn-cs"/>
               </a:rPr>
               <a:t>Any Resources</a:t>
             </a:r>
@@ -3394,7 +4039,13 @@
       </p:sp>
       <p:sp>
         <p:nvSpPr>
-          <p:cNvPr id="12" name="Flowchart: Alternate Process 11"/>
+          <p:cNvPr id="12" name="Flowchart: Alternate Process 11">
+            <a:extLst>
+              <a:ext uri="{FF2B5EF4-FFF2-40B4-BE49-F238E27FC236}">
+                <a16:creationId xmlns:a16="http://schemas.microsoft.com/office/drawing/2014/main" id="{340C1B5D-7211-BC97-BC29-5F71B7E1022D}"/>
+              </a:ext>
+            </a:extLst>
+          </p:cNvPr>
           <p:cNvSpPr/>
           <p:nvPr/>
         </p:nvSpPr>
@@ -3432,12 +4083,37 @@
           <a:bodyPr rtlCol="0" anchor="ctr"/>
           <a:lstStyle/>
           <a:p>
-            <a:pPr algn="ctr"/>
-            <a:r>
-              <a:rPr lang="en-US" sz="1400" dirty="0">
+            <a:pPr marL="0" marR="0" lvl="0" indent="0" algn="ctr" defTabSz="914400" rtl="0" eaLnBrk="1" fontAlgn="auto" latinLnBrk="0" hangingPunct="1">
+              <a:lnSpc>
+                <a:spcPct val="100000"/>
+              </a:lnSpc>
+              <a:spcBef>
+                <a:spcPts val="0"/>
+              </a:spcBef>
+              <a:spcAft>
+                <a:spcPts val="0"/>
+              </a:spcAft>
+              <a:buClrTx/>
+              <a:buSzTx/>
+              <a:buFontTx/>
+              <a:buNone/>
+              <a:tabLst/>
+              <a:defRPr/>
+            </a:pPr>
+            <a:r>
+              <a:rPr kumimoji="0" lang="en-US" sz="1400" b="0" i="0" u="none" strike="noStrike" kern="1200" cap="none" spc="0" normalizeH="0" baseline="0" noProof="0" dirty="0">
+                <a:ln>
+                  <a:noFill/>
+                </a:ln>
                 <a:solidFill>
-                  <a:schemeClr val="bg1"/>
+                  <a:prstClr val="white"/>
                 </a:solidFill>
+                <a:effectLst/>
+                <a:uLnTx/>
+                <a:uFillTx/>
+                <a:latin typeface="Calibri"/>
+                <a:ea typeface="+mn-ea"/>
+                <a:cs typeface="+mn-cs"/>
               </a:rPr>
               <a:t>Any Resource</a:t>
             </a:r>
@@ -3446,14 +4122,20 @@
       </p:sp>
       <p:sp>
         <p:nvSpPr>
-          <p:cNvPr id="14" name="Flowchart: Alternate Process 13"/>
+          <p:cNvPr id="14" name="Flowchart: Alternate Process 13">
+            <a:extLst>
+              <a:ext uri="{FF2B5EF4-FFF2-40B4-BE49-F238E27FC236}">
+                <a16:creationId xmlns:a16="http://schemas.microsoft.com/office/drawing/2014/main" id="{5441AE4F-C997-2832-59D9-A48ADABCA67D}"/>
+              </a:ext>
+            </a:extLst>
+          </p:cNvPr>
           <p:cNvSpPr/>
           <p:nvPr/>
         </p:nvSpPr>
         <p:spPr>
           <a:xfrm>
-            <a:off x="5943600" y="1981200"/>
-            <a:ext cx="1524000" cy="609600"/>
+            <a:off x="5943600" y="1752600"/>
+            <a:ext cx="1524000" cy="838200"/>
           </a:xfrm>
           <a:prstGeom prst="flowChartAlternateProcess">
             <a:avLst/>
@@ -3484,28 +4166,131 @@
           <a:bodyPr rtlCol="0" anchor="ctr"/>
           <a:lstStyle/>
           <a:p>
-            <a:pPr algn="ctr"/>
-            <a:r>
-              <a:rPr lang="en-US" sz="1400" dirty="0">
+            <a:pPr marL="0" marR="0" lvl="0" indent="0" algn="ctr" defTabSz="914400" rtl="0" eaLnBrk="1" fontAlgn="auto" latinLnBrk="0" hangingPunct="1">
+              <a:lnSpc>
+                <a:spcPct val="100000"/>
+              </a:lnSpc>
+              <a:spcBef>
+                <a:spcPts val="0"/>
+              </a:spcBef>
+              <a:spcAft>
+                <a:spcPts val="0"/>
+              </a:spcAft>
+              <a:buClrTx/>
+              <a:buSzTx/>
+              <a:buFontTx/>
+              <a:buNone/>
+              <a:tabLst/>
+              <a:defRPr/>
+            </a:pPr>
+            <a:r>
+              <a:rPr kumimoji="0" lang="en-US" sz="1400" b="0" i="0" u="none" strike="noStrike" kern="1200" cap="none" spc="0" normalizeH="0" baseline="0" noProof="0" dirty="0">
+                <a:ln>
+                  <a:noFill/>
+                </a:ln>
                 <a:solidFill>
-                  <a:schemeClr val="bg1"/>
+                  <a:prstClr val="white"/>
                 </a:solidFill>
+                <a:effectLst/>
+                <a:uLnTx/>
+                <a:uFillTx/>
+                <a:latin typeface="Calibri"/>
+                <a:ea typeface="+mn-ea"/>
+                <a:cs typeface="+mn-cs"/>
               </a:rPr>
               <a:t>Organization</a:t>
             </a:r>
           </a:p>
-        </p:txBody>
-      </p:sp>
-      <p:sp>
-        <p:nvSpPr>
-          <p:cNvPr id="15" name="Flowchart: Alternate Process 14"/>
+          <a:p>
+            <a:pPr marL="0" marR="0" lvl="0" indent="0" algn="ctr" defTabSz="914400" rtl="0" eaLnBrk="1" fontAlgn="auto" latinLnBrk="0" hangingPunct="1">
+              <a:lnSpc>
+                <a:spcPct val="100000"/>
+              </a:lnSpc>
+              <a:spcBef>
+                <a:spcPts val="0"/>
+              </a:spcBef>
+              <a:spcAft>
+                <a:spcPts val="0"/>
+              </a:spcAft>
+              <a:buClrTx/>
+              <a:buSzTx/>
+              <a:buFontTx/>
+              <a:buNone/>
+              <a:tabLst/>
+              <a:defRPr/>
+            </a:pPr>
+            <a:r>
+              <a:rPr kumimoji="0" lang="en-US" sz="1400" b="0" i="0" u="none" strike="noStrike" kern="1200" cap="none" spc="0" normalizeH="0" baseline="0" noProof="0" dirty="0">
+                <a:ln>
+                  <a:noFill/>
+                </a:ln>
+                <a:solidFill>
+                  <a:prstClr val="white"/>
+                </a:solidFill>
+                <a:effectLst/>
+                <a:uLnTx/>
+                <a:uFillTx/>
+                <a:latin typeface="Calibri"/>
+                <a:ea typeface="+mn-ea"/>
+                <a:cs typeface="+mn-cs"/>
+              </a:rPr>
+              <a:t>Practitioner</a:t>
+            </a:r>
+          </a:p>
+          <a:p>
+            <a:pPr marL="0" marR="0" lvl="0" indent="0" algn="ctr" defTabSz="914400" rtl="0" eaLnBrk="1" fontAlgn="auto" latinLnBrk="0" hangingPunct="1">
+              <a:lnSpc>
+                <a:spcPct val="100000"/>
+              </a:lnSpc>
+              <a:spcBef>
+                <a:spcPts val="0"/>
+              </a:spcBef>
+              <a:spcAft>
+                <a:spcPts val="0"/>
+              </a:spcAft>
+              <a:buClrTx/>
+              <a:buSzTx/>
+              <a:buFontTx/>
+              <a:buNone/>
+              <a:tabLst/>
+              <a:defRPr/>
+            </a:pPr>
+            <a:r>
+              <a:rPr kumimoji="0" lang="en-US" sz="1400" b="0" i="0" u="none" strike="noStrike" kern="1200" cap="none" spc="0" normalizeH="0" baseline="0" noProof="0" dirty="0">
+                <a:ln>
+                  <a:noFill/>
+                </a:ln>
+                <a:solidFill>
+                  <a:prstClr val="white"/>
+                </a:solidFill>
+                <a:effectLst/>
+                <a:uLnTx/>
+                <a:uFillTx/>
+                <a:latin typeface="Calibri"/>
+                <a:ea typeface="+mn-ea"/>
+                <a:cs typeface="+mn-cs"/>
+              </a:rPr>
+              <a:t>Practitioner Role</a:t>
+            </a:r>
+          </a:p>
+        </p:txBody>
+      </p:sp>
+      <p:sp>
+        <p:nvSpPr>
+          <p:cNvPr id="15" name="Flowchart: Alternate Process 14">
+            <a:extLst>
+              <a:ext uri="{FF2B5EF4-FFF2-40B4-BE49-F238E27FC236}">
+                <a16:creationId xmlns:a16="http://schemas.microsoft.com/office/drawing/2014/main" id="{9D4070F8-8F74-AA5D-A506-D2F29338A0CA}"/>
+              </a:ext>
+            </a:extLst>
+          </p:cNvPr>
           <p:cNvSpPr/>
           <p:nvPr/>
         </p:nvSpPr>
         <p:spPr>
           <a:xfrm>
-            <a:off x="5943600" y="3935834"/>
-            <a:ext cx="1524000" cy="609600"/>
+            <a:off x="5943599" y="3935834"/>
+            <a:ext cx="1564937" cy="2007766"/>
           </a:xfrm>
           <a:prstGeom prst="flowChartAlternateProcess">
             <a:avLst/>
@@ -3536,21 +4321,268 @@
           <a:bodyPr rtlCol="0" anchor="ctr"/>
           <a:lstStyle/>
           <a:p>
-            <a:pPr algn="ctr"/>
-            <a:r>
-              <a:rPr lang="en-US" sz="1400" dirty="0">
+            <a:pPr marL="0" marR="0" lvl="0" indent="0" algn="ctr" defTabSz="914400" rtl="0" eaLnBrk="1" fontAlgn="auto" latinLnBrk="0" hangingPunct="1">
+              <a:lnSpc>
+                <a:spcPct val="100000"/>
+              </a:lnSpc>
+              <a:spcBef>
+                <a:spcPts val="0"/>
+              </a:spcBef>
+              <a:spcAft>
+                <a:spcPts val="0"/>
+              </a:spcAft>
+              <a:buClrTx/>
+              <a:buSzTx/>
+              <a:buFontTx/>
+              <a:buNone/>
+              <a:tabLst/>
+              <a:defRPr/>
+            </a:pPr>
+            <a:r>
+              <a:rPr kumimoji="0" lang="en-US" sz="1400" b="0" i="0" u="none" strike="noStrike" kern="1200" cap="none" spc="0" normalizeH="0" baseline="0" noProof="0" dirty="0">
+                <a:ln>
+                  <a:noFill/>
+                </a:ln>
                 <a:solidFill>
-                  <a:schemeClr val="bg1"/>
+                  <a:prstClr val="white"/>
                 </a:solidFill>
+                <a:effectLst/>
+                <a:uLnTx/>
+                <a:uFillTx/>
+                <a:latin typeface="Calibri"/>
+                <a:ea typeface="+mn-ea"/>
+                <a:cs typeface="+mn-cs"/>
               </a:rPr>
               <a:t>Patient</a:t>
             </a:r>
           </a:p>
+          <a:p>
+            <a:pPr marL="0" marR="0" lvl="0" indent="0" algn="ctr" defTabSz="914400" rtl="0" eaLnBrk="1" fontAlgn="auto" latinLnBrk="0" hangingPunct="1">
+              <a:lnSpc>
+                <a:spcPct val="100000"/>
+              </a:lnSpc>
+              <a:spcBef>
+                <a:spcPts val="0"/>
+              </a:spcBef>
+              <a:spcAft>
+                <a:spcPts val="0"/>
+              </a:spcAft>
+              <a:buClrTx/>
+              <a:buSzTx/>
+              <a:buFontTx/>
+              <a:buNone/>
+              <a:tabLst/>
+              <a:defRPr/>
+            </a:pPr>
+            <a:r>
+              <a:rPr kumimoji="0" lang="en-US" sz="1400" b="0" i="0" u="none" strike="noStrike" kern="1200" cap="none" spc="0" normalizeH="0" baseline="0" noProof="0" dirty="0">
+                <a:ln>
+                  <a:noFill/>
+                </a:ln>
+                <a:solidFill>
+                  <a:prstClr val="white"/>
+                </a:solidFill>
+                <a:effectLst/>
+                <a:uLnTx/>
+                <a:uFillTx/>
+                <a:latin typeface="Calibri"/>
+                <a:ea typeface="+mn-ea"/>
+                <a:cs typeface="+mn-cs"/>
+              </a:rPr>
+              <a:t>Practitioner</a:t>
+            </a:r>
+          </a:p>
+          <a:p>
+            <a:pPr marL="0" marR="0" lvl="0" indent="0" algn="ctr" defTabSz="914400" rtl="0" eaLnBrk="1" fontAlgn="auto" latinLnBrk="0" hangingPunct="1">
+              <a:lnSpc>
+                <a:spcPct val="100000"/>
+              </a:lnSpc>
+              <a:spcBef>
+                <a:spcPts val="0"/>
+              </a:spcBef>
+              <a:spcAft>
+                <a:spcPts val="0"/>
+              </a:spcAft>
+              <a:buClrTx/>
+              <a:buSzTx/>
+              <a:buFontTx/>
+              <a:buNone/>
+              <a:tabLst/>
+              <a:defRPr/>
+            </a:pPr>
+            <a:r>
+              <a:rPr kumimoji="0" lang="en-US" sz="1400" b="0" i="0" u="none" strike="noStrike" kern="1200" cap="none" spc="0" normalizeH="0" baseline="0" noProof="0" dirty="0">
+                <a:ln>
+                  <a:noFill/>
+                </a:ln>
+                <a:solidFill>
+                  <a:prstClr val="white"/>
+                </a:solidFill>
+                <a:effectLst/>
+                <a:uLnTx/>
+                <a:uFillTx/>
+                <a:latin typeface="Calibri"/>
+                <a:ea typeface="+mn-ea"/>
+                <a:cs typeface="+mn-cs"/>
+              </a:rPr>
+              <a:t>Practitioner Role</a:t>
+            </a:r>
+          </a:p>
+          <a:p>
+            <a:pPr marL="0" marR="0" lvl="0" indent="0" algn="ctr" defTabSz="914400" rtl="0" eaLnBrk="1" fontAlgn="auto" latinLnBrk="0" hangingPunct="1">
+              <a:lnSpc>
+                <a:spcPct val="100000"/>
+              </a:lnSpc>
+              <a:spcBef>
+                <a:spcPts val="0"/>
+              </a:spcBef>
+              <a:spcAft>
+                <a:spcPts val="0"/>
+              </a:spcAft>
+              <a:buClrTx/>
+              <a:buSzTx/>
+              <a:buFontTx/>
+              <a:buNone/>
+              <a:tabLst/>
+              <a:defRPr/>
+            </a:pPr>
+            <a:r>
+              <a:rPr kumimoji="0" lang="en-US" sz="1400" b="0" i="0" u="none" strike="noStrike" kern="1200" cap="none" spc="0" normalizeH="0" baseline="0" noProof="0" dirty="0">
+                <a:ln>
+                  <a:noFill/>
+                </a:ln>
+                <a:solidFill>
+                  <a:prstClr val="white"/>
+                </a:solidFill>
+                <a:effectLst/>
+                <a:uLnTx/>
+                <a:uFillTx/>
+                <a:latin typeface="Calibri"/>
+                <a:ea typeface="+mn-ea"/>
+                <a:cs typeface="+mn-cs"/>
+              </a:rPr>
+              <a:t>Location</a:t>
+            </a:r>
+          </a:p>
+          <a:p>
+            <a:pPr marL="0" marR="0" lvl="0" indent="0" algn="ctr" defTabSz="914400" rtl="0" eaLnBrk="1" fontAlgn="auto" latinLnBrk="0" hangingPunct="1">
+              <a:lnSpc>
+                <a:spcPct val="100000"/>
+              </a:lnSpc>
+              <a:spcBef>
+                <a:spcPts val="0"/>
+              </a:spcBef>
+              <a:spcAft>
+                <a:spcPts val="0"/>
+              </a:spcAft>
+              <a:buClrTx/>
+              <a:buSzTx/>
+              <a:buFontTx/>
+              <a:buNone/>
+              <a:tabLst/>
+              <a:defRPr/>
+            </a:pPr>
+            <a:r>
+              <a:rPr kumimoji="0" lang="en-US" sz="1400" b="0" i="0" u="none" strike="noStrike" kern="1200" cap="none" spc="0" normalizeH="0" baseline="0" noProof="0" dirty="0">
+                <a:ln>
+                  <a:noFill/>
+                </a:ln>
+                <a:solidFill>
+                  <a:prstClr val="white"/>
+                </a:solidFill>
+                <a:effectLst/>
+                <a:uLnTx/>
+                <a:uFillTx/>
+                <a:latin typeface="Calibri"/>
+                <a:ea typeface="+mn-ea"/>
+                <a:cs typeface="+mn-cs"/>
+              </a:rPr>
+              <a:t>Device</a:t>
+            </a:r>
+          </a:p>
+          <a:p>
+            <a:pPr marL="0" marR="0" lvl="0" indent="0" algn="ctr" defTabSz="914400" rtl="0" eaLnBrk="1" fontAlgn="auto" latinLnBrk="0" hangingPunct="1">
+              <a:lnSpc>
+                <a:spcPct val="100000"/>
+              </a:lnSpc>
+              <a:spcBef>
+                <a:spcPts val="0"/>
+              </a:spcBef>
+              <a:spcAft>
+                <a:spcPts val="0"/>
+              </a:spcAft>
+              <a:buClrTx/>
+              <a:buSzTx/>
+              <a:buFontTx/>
+              <a:buNone/>
+              <a:tabLst/>
+              <a:defRPr/>
+            </a:pPr>
+            <a:r>
+              <a:rPr kumimoji="0" lang="en-US" sz="1400" b="0" i="0" u="none" strike="noStrike" kern="1200" cap="none" spc="0" normalizeH="0" baseline="0" noProof="0" dirty="0">
+                <a:ln>
+                  <a:noFill/>
+                </a:ln>
+                <a:solidFill>
+                  <a:prstClr val="white"/>
+                </a:solidFill>
+                <a:effectLst/>
+                <a:uLnTx/>
+                <a:uFillTx/>
+                <a:latin typeface="Calibri"/>
+                <a:ea typeface="+mn-ea"/>
+                <a:cs typeface="+mn-cs"/>
+              </a:rPr>
+              <a:t>Related Person</a:t>
+            </a:r>
+          </a:p>
+          <a:p>
+            <a:pPr marL="0" marR="0" lvl="0" indent="0" algn="ctr" defTabSz="914400" rtl="0" eaLnBrk="1" fontAlgn="auto" latinLnBrk="0" hangingPunct="1">
+              <a:lnSpc>
+                <a:spcPct val="100000"/>
+              </a:lnSpc>
+              <a:spcBef>
+                <a:spcPts val="0"/>
+              </a:spcBef>
+              <a:spcAft>
+                <a:spcPts val="0"/>
+              </a:spcAft>
+              <a:buClrTx/>
+              <a:buSzTx/>
+              <a:buFontTx/>
+              <a:buNone/>
+              <a:tabLst/>
+              <a:defRPr/>
+            </a:pPr>
+            <a:r>
+              <a:rPr kumimoji="0" lang="en-US" sz="1400" b="0" i="0" u="none" strike="noStrike" kern="1200" cap="none" spc="0" normalizeH="0" baseline="0" noProof="0" dirty="0">
+                <a:ln>
+                  <a:noFill/>
+                </a:ln>
+                <a:solidFill>
+                  <a:prstClr val="white"/>
+                </a:solidFill>
+                <a:effectLst/>
+                <a:uLnTx/>
+                <a:uFillTx/>
+                <a:latin typeface="Calibri"/>
+                <a:ea typeface="+mn-ea"/>
+                <a:cs typeface="+mn-cs"/>
+              </a:rPr>
+              <a:t>Group</a:t>
+            </a:r>
+          </a:p>
         </p:txBody>
       </p:sp>
       <p:cxnSp>
         <p:nvCxnSpPr>
-          <p:cNvPr id="17" name="Straight Arrow Connector 16"/>
+          <p:cNvPr id="17" name="Straight Arrow Connector 16">
+            <a:extLst>
+              <a:ext uri="{FF2B5EF4-FFF2-40B4-BE49-F238E27FC236}">
+                <a16:creationId xmlns:a16="http://schemas.microsoft.com/office/drawing/2014/main" id="{8EE2E13C-6B65-DE4C-D8B9-CFB815842534}"/>
+              </a:ext>
+            </a:extLst>
+          </p:cNvPr>
           <p:cNvCxnSpPr>
             <a:stCxn id="6" idx="0"/>
             <a:endCxn id="4" idx="2"/>
@@ -3589,14 +4621,23 @@
       </p:cxnSp>
       <p:cxnSp>
         <p:nvCxnSpPr>
-          <p:cNvPr id="19" name="Straight Arrow Connector 18"/>
-          <p:cNvCxnSpPr/>
+          <p:cNvPr id="19" name="Straight Arrow Connector 18">
+            <a:extLst>
+              <a:ext uri="{FF2B5EF4-FFF2-40B4-BE49-F238E27FC236}">
+                <a16:creationId xmlns:a16="http://schemas.microsoft.com/office/drawing/2014/main" id="{011C52C1-1F04-AD92-22D7-030B4DA1EA30}"/>
+              </a:ext>
+            </a:extLst>
+          </p:cNvPr>
+          <p:cNvCxnSpPr>
+            <a:cxnSpLocks/>
+            <a:stCxn id="6" idx="2"/>
+          </p:cNvCxnSpPr>
           <p:nvPr/>
         </p:nvCxnSpPr>
         <p:spPr>
           <a:xfrm>
-            <a:off x="2454613" y="3654357"/>
-            <a:ext cx="0" cy="993843"/>
+            <a:off x="2438400" y="3746770"/>
+            <a:ext cx="16213" cy="901430"/>
           </a:xfrm>
           <a:prstGeom prst="straightConnector1">
             <a:avLst/>
@@ -3625,7 +4666,13 @@
       </p:cxnSp>
       <p:sp>
         <p:nvSpPr>
-          <p:cNvPr id="23" name="TextBox 22"/>
+          <p:cNvPr id="23" name="TextBox 22">
+            <a:extLst>
+              <a:ext uri="{FF2B5EF4-FFF2-40B4-BE49-F238E27FC236}">
+                <a16:creationId xmlns:a16="http://schemas.microsoft.com/office/drawing/2014/main" id="{D142FAFB-17DA-47B6-AE7F-D318E8F75FA8}"/>
+              </a:ext>
+            </a:extLst>
+          </p:cNvPr>
           <p:cNvSpPr txBox="1"/>
           <p:nvPr/>
         </p:nvSpPr>
@@ -3647,9 +4694,38 @@
           </a:bodyPr>
           <a:lstStyle/>
           <a:p>
-            <a:pPr algn="ctr"/>
-            <a:r>
-              <a:rPr lang="en-US" sz="1100" b="1" dirty="0"/>
+            <a:pPr marL="0" marR="0" lvl="0" indent="0" algn="ctr" defTabSz="914400" rtl="0" eaLnBrk="1" fontAlgn="auto" latinLnBrk="0" hangingPunct="1">
+              <a:lnSpc>
+                <a:spcPct val="100000"/>
+              </a:lnSpc>
+              <a:spcBef>
+                <a:spcPts val="0"/>
+              </a:spcBef>
+              <a:spcAft>
+                <a:spcPts val="0"/>
+              </a:spcAft>
+              <a:buClrTx/>
+              <a:buSzTx/>
+              <a:buFontTx/>
+              <a:buNone/>
+              <a:tabLst/>
+              <a:defRPr/>
+            </a:pPr>
+            <a:r>
+              <a:rPr kumimoji="0" lang="en-US" sz="1100" b="1" i="0" u="none" strike="noStrike" kern="1200" cap="none" spc="0" normalizeH="0" baseline="0" noProof="0" dirty="0">
+                <a:ln>
+                  <a:noFill/>
+                </a:ln>
+                <a:solidFill>
+                  <a:prstClr val="black"/>
+                </a:solidFill>
+                <a:effectLst/>
+                <a:uLnTx/>
+                <a:uFillTx/>
+                <a:latin typeface="Calibri"/>
+                <a:ea typeface="+mn-ea"/>
+                <a:cs typeface="+mn-cs"/>
+              </a:rPr>
               <a:t>measure</a:t>
             </a:r>
           </a:p>
@@ -3657,16 +4733,23 @@
       </p:sp>
       <p:cxnSp>
         <p:nvCxnSpPr>
-          <p:cNvPr id="26" name="Straight Arrow Connector 25"/>
+          <p:cNvPr id="26" name="Straight Arrow Connector 25">
+            <a:extLst>
+              <a:ext uri="{FF2B5EF4-FFF2-40B4-BE49-F238E27FC236}">
+                <a16:creationId xmlns:a16="http://schemas.microsoft.com/office/drawing/2014/main" id="{150BE3F9-B731-A1FD-C2DE-2C949A478245}"/>
+              </a:ext>
+            </a:extLst>
+          </p:cNvPr>
           <p:cNvCxnSpPr>
+            <a:cxnSpLocks/>
             <a:endCxn id="14" idx="1"/>
           </p:cNvCxnSpPr>
           <p:nvPr/>
         </p:nvCxnSpPr>
         <p:spPr>
           <a:xfrm flipV="1">
-            <a:off x="3200400" y="2286000"/>
-            <a:ext cx="2743200" cy="1148448"/>
+            <a:off x="3200400" y="2171700"/>
+            <a:ext cx="2743200" cy="1034148"/>
           </a:xfrm>
           <a:prstGeom prst="straightConnector1">
             <a:avLst/>
@@ -3695,8 +4778,15 @@
       </p:cxnSp>
       <p:cxnSp>
         <p:nvCxnSpPr>
-          <p:cNvPr id="30" name="Straight Arrow Connector 29"/>
+          <p:cNvPr id="30" name="Straight Arrow Connector 29">
+            <a:extLst>
+              <a:ext uri="{FF2B5EF4-FFF2-40B4-BE49-F238E27FC236}">
+                <a16:creationId xmlns:a16="http://schemas.microsoft.com/office/drawing/2014/main" id="{607C5B5C-01E9-8325-8023-ABCE951A9D6D}"/>
+              </a:ext>
+            </a:extLst>
+          </p:cNvPr>
           <p:cNvCxnSpPr>
+            <a:cxnSpLocks/>
             <a:stCxn id="6" idx="3"/>
             <a:endCxn id="15" idx="1"/>
           </p:cNvCxnSpPr>
@@ -3705,7 +4795,7 @@
         <p:spPr>
           <a:xfrm>
             <a:off x="3200400" y="3441970"/>
-            <a:ext cx="2743200" cy="798664"/>
+            <a:ext cx="2743199" cy="1497747"/>
           </a:xfrm>
           <a:prstGeom prst="straightConnector1">
             <a:avLst/>
@@ -3734,13 +4824,19 @@
       </p:cxnSp>
       <p:sp>
         <p:nvSpPr>
-          <p:cNvPr id="32" name="TextBox 31"/>
+          <p:cNvPr id="32" name="TextBox 31">
+            <a:extLst>
+              <a:ext uri="{FF2B5EF4-FFF2-40B4-BE49-F238E27FC236}">
+                <a16:creationId xmlns:a16="http://schemas.microsoft.com/office/drawing/2014/main" id="{544C703B-DCDE-F203-2C62-EFD0BC2D6282}"/>
+              </a:ext>
+            </a:extLst>
+          </p:cNvPr>
           <p:cNvSpPr txBox="1"/>
           <p:nvPr/>
         </p:nvSpPr>
         <p:spPr>
           <a:xfrm>
-            <a:off x="4038600" y="2635385"/>
+            <a:off x="3581400" y="2590800"/>
             <a:ext cx="1676400" cy="261610"/>
           </a:xfrm>
           <a:prstGeom prst="rect">
@@ -3756,9 +4852,38 @@
           </a:bodyPr>
           <a:lstStyle/>
           <a:p>
-            <a:pPr algn="ctr"/>
-            <a:r>
-              <a:rPr lang="en-US" sz="1100" b="1" dirty="0"/>
+            <a:pPr marL="0" marR="0" lvl="0" indent="0" algn="ctr" defTabSz="914400" rtl="0" eaLnBrk="1" fontAlgn="auto" latinLnBrk="0" hangingPunct="1">
+              <a:lnSpc>
+                <a:spcPct val="100000"/>
+              </a:lnSpc>
+              <a:spcBef>
+                <a:spcPts val="0"/>
+              </a:spcBef>
+              <a:spcAft>
+                <a:spcPts val="0"/>
+              </a:spcAft>
+              <a:buClrTx/>
+              <a:buSzTx/>
+              <a:buFontTx/>
+              <a:buNone/>
+              <a:tabLst/>
+              <a:defRPr/>
+            </a:pPr>
+            <a:r>
+              <a:rPr kumimoji="0" lang="en-US" sz="1100" b="1" i="0" u="none" strike="noStrike" kern="1200" cap="none" spc="0" normalizeH="0" baseline="0" noProof="0" dirty="0">
+                <a:ln>
+                  <a:noFill/>
+                </a:ln>
+                <a:solidFill>
+                  <a:prstClr val="black"/>
+                </a:solidFill>
+                <a:effectLst/>
+                <a:uLnTx/>
+                <a:uFillTx/>
+                <a:latin typeface="Calibri"/>
+                <a:ea typeface="+mn-ea"/>
+                <a:cs typeface="+mn-cs"/>
+              </a:rPr>
               <a:t>reporter</a:t>
             </a:r>
           </a:p>
@@ -3766,7 +4891,13 @@
       </p:sp>
       <p:sp>
         <p:nvSpPr>
-          <p:cNvPr id="34" name="TextBox 33"/>
+          <p:cNvPr id="34" name="TextBox 33">
+            <a:extLst>
+              <a:ext uri="{FF2B5EF4-FFF2-40B4-BE49-F238E27FC236}">
+                <a16:creationId xmlns:a16="http://schemas.microsoft.com/office/drawing/2014/main" id="{1A38EE44-F33F-ECF7-4B44-A2F9AC73B3CC}"/>
+              </a:ext>
+            </a:extLst>
+          </p:cNvPr>
           <p:cNvSpPr txBox="1"/>
           <p:nvPr/>
         </p:nvSpPr>
@@ -3788,24 +4919,58 @@
           </a:bodyPr>
           <a:lstStyle/>
           <a:p>
-            <a:pPr algn="ctr"/>
-            <a:r>
-              <a:rPr lang="en-US" sz="1100" b="1" dirty="0" err="1"/>
+            <a:pPr marL="0" marR="0" lvl="0" indent="0" algn="ctr" defTabSz="914400" rtl="0" eaLnBrk="1" fontAlgn="auto" latinLnBrk="0" hangingPunct="1">
+              <a:lnSpc>
+                <a:spcPct val="100000"/>
+              </a:lnSpc>
+              <a:spcBef>
+                <a:spcPts val="0"/>
+              </a:spcBef>
+              <a:spcAft>
+                <a:spcPts val="0"/>
+              </a:spcAft>
+              <a:buClrTx/>
+              <a:buSzTx/>
+              <a:buFontTx/>
+              <a:buNone/>
+              <a:tabLst/>
+              <a:defRPr/>
+            </a:pPr>
+            <a:r>
+              <a:rPr kumimoji="0" lang="en-US" sz="1100" b="1" i="0" u="none" strike="noStrike" kern="1200" cap="none" spc="0" normalizeH="0" baseline="0" noProof="0" dirty="0">
+                <a:ln>
+                  <a:noFill/>
+                </a:ln>
+                <a:solidFill>
+                  <a:prstClr val="black"/>
+                </a:solidFill>
+                <a:effectLst/>
+                <a:uLnTx/>
+                <a:uFillTx/>
+                <a:latin typeface="Calibri"/>
+                <a:ea typeface="+mn-ea"/>
+                <a:cs typeface="+mn-cs"/>
+              </a:rPr>
               <a:t>evaluatedResource</a:t>
             </a:r>
-            <a:endParaRPr lang="en-US" sz="1100" b="1" dirty="0"/>
-          </a:p>
-        </p:txBody>
-      </p:sp>
-      <p:sp>
-        <p:nvSpPr>
-          <p:cNvPr id="35" name="TextBox 34"/>
+          </a:p>
+        </p:txBody>
+      </p:sp>
+      <p:sp>
+        <p:nvSpPr>
+          <p:cNvPr id="35" name="TextBox 34">
+            <a:extLst>
+              <a:ext uri="{FF2B5EF4-FFF2-40B4-BE49-F238E27FC236}">
+                <a16:creationId xmlns:a16="http://schemas.microsoft.com/office/drawing/2014/main" id="{B7F98716-384A-6570-8F35-C6F7A5E5AD64}"/>
+              </a:ext>
+            </a:extLst>
+          </p:cNvPr>
           <p:cNvSpPr txBox="1"/>
           <p:nvPr/>
         </p:nvSpPr>
         <p:spPr>
           <a:xfrm>
-            <a:off x="4101019" y="3727812"/>
+            <a:off x="3848100" y="4005590"/>
             <a:ext cx="1143000" cy="261610"/>
           </a:xfrm>
           <a:prstGeom prst="rect">
@@ -3821,10 +4986,39 @@
           </a:bodyPr>
           <a:lstStyle/>
           <a:p>
-            <a:pPr algn="ctr"/>
-            <a:r>
-              <a:rPr lang="en-US" sz="1100" b="1" dirty="0"/>
-              <a:t>patient</a:t>
+            <a:pPr marL="0" marR="0" lvl="0" indent="0" algn="ctr" defTabSz="914400" rtl="0" eaLnBrk="1" fontAlgn="auto" latinLnBrk="0" hangingPunct="1">
+              <a:lnSpc>
+                <a:spcPct val="100000"/>
+              </a:lnSpc>
+              <a:spcBef>
+                <a:spcPts val="0"/>
+              </a:spcBef>
+              <a:spcAft>
+                <a:spcPts val="0"/>
+              </a:spcAft>
+              <a:buClrTx/>
+              <a:buSzTx/>
+              <a:buFontTx/>
+              <a:buNone/>
+              <a:tabLst/>
+              <a:defRPr/>
+            </a:pPr>
+            <a:r>
+              <a:rPr kumimoji="0" lang="en-US" sz="1100" b="1" i="0" u="none" strike="noStrike" kern="1200" cap="none" spc="0" normalizeH="0" baseline="0" noProof="0" dirty="0">
+                <a:ln>
+                  <a:noFill/>
+                </a:ln>
+                <a:solidFill>
+                  <a:prstClr val="black"/>
+                </a:solidFill>
+                <a:effectLst/>
+                <a:uLnTx/>
+                <a:uFillTx/>
+                <a:latin typeface="Calibri"/>
+                <a:ea typeface="+mn-ea"/>
+                <a:cs typeface="+mn-cs"/>
+              </a:rPr>
+              <a:t>subject</a:t>
             </a:r>
           </a:p>
         </p:txBody>
@@ -3832,7 +5026,7 @@
     </p:spTree>
     <p:extLst>
       <p:ext uri="{BB962C8B-B14F-4D97-AF65-F5344CB8AC3E}">
-        <p14:creationId xmlns:p14="http://schemas.microsoft.com/office/powerpoint/2010/main" val="1021895600"/>
+        <p14:creationId xmlns:p14="http://schemas.microsoft.com/office/powerpoint/2010/main" val="679530087"/>
       </p:ext>
     </p:extLst>
   </p:cSld>
@@ -4125,4 +5319,319 @@
   <a:objectDefaults/>
   <a:extraClrSchemeLst/>
 </a:theme>
+</file>
+
+<file path=ppt/theme/theme2.xml><?xml version="1.0" encoding="utf-8"?>
+<a:theme xmlns:a="http://schemas.openxmlformats.org/drawingml/2006/main" name="Office Theme">
+  <a:themeElements>
+    <a:clrScheme name="Office">
+      <a:dk1>
+        <a:sysClr val="windowText" lastClr="000000"/>
+      </a:dk1>
+      <a:lt1>
+        <a:sysClr val="window" lastClr="FFFFFF"/>
+      </a:lt1>
+      <a:dk2>
+        <a:srgbClr val="0E2841"/>
+      </a:dk2>
+      <a:lt2>
+        <a:srgbClr val="E8E8E8"/>
+      </a:lt2>
+      <a:accent1>
+        <a:srgbClr val="156082"/>
+      </a:accent1>
+      <a:accent2>
+        <a:srgbClr val="E97132"/>
+      </a:accent2>
+      <a:accent3>
+        <a:srgbClr val="196B24"/>
+      </a:accent3>
+      <a:accent4>
+        <a:srgbClr val="0F9ED5"/>
+      </a:accent4>
+      <a:accent5>
+        <a:srgbClr val="A02B93"/>
+      </a:accent5>
+      <a:accent6>
+        <a:srgbClr val="4EA72E"/>
+      </a:accent6>
+      <a:hlink>
+        <a:srgbClr val="467886"/>
+      </a:hlink>
+      <a:folHlink>
+        <a:srgbClr val="96607D"/>
+      </a:folHlink>
+    </a:clrScheme>
+    <a:fontScheme name="Office">
+      <a:majorFont>
+        <a:latin typeface="Aptos Display" panose="02110004020202020204"/>
+        <a:ea typeface=""/>
+        <a:cs typeface=""/>
+        <a:font script="Jpan" typeface="游ゴシック Light"/>
+        <a:font script="Hang" typeface="맑은 고딕"/>
+        <a:font script="Hans" typeface="等线 Light"/>
+        <a:font script="Hant" typeface="新細明體"/>
+        <a:font script="Arab" typeface="Times New Roman"/>
+        <a:font script="Hebr" typeface="Times New Roman"/>
+        <a:font script="Thai" typeface="Angsana New"/>
+        <a:font script="Ethi" typeface="Nyala"/>
+        <a:font script="Beng" typeface="Vrinda"/>
+        <a:font script="Gujr" typeface="Shruti"/>
+        <a:font script="Khmr" typeface="MoolBoran"/>
+        <a:font script="Knda" typeface="Tunga"/>
+        <a:font script="Guru" typeface="Raavi"/>
+        <a:font script="Cans" typeface="Euphemia"/>
+        <a:font script="Cher" typeface="Plantagenet Cherokee"/>
+        <a:font script="Yiii" typeface="Microsoft Yi Baiti"/>
+        <a:font script="Tibt" typeface="Microsoft Himalaya"/>
+        <a:font script="Thaa" typeface="MV Boli"/>
+        <a:font script="Deva" typeface="Mangal"/>
+        <a:font script="Telu" typeface="Gautami"/>
+        <a:font script="Taml" typeface="Latha"/>
+        <a:font script="Syrc" typeface="Estrangelo Edessa"/>
+        <a:font script="Orya" typeface="Kalinga"/>
+        <a:font script="Mlym" typeface="Kartika"/>
+        <a:font script="Laoo" typeface="DokChampa"/>
+        <a:font script="Sinh" typeface="Iskoola Pota"/>
+        <a:font script="Mong" typeface="Mongolian Baiti"/>
+        <a:font script="Viet" typeface="Times New Roman"/>
+        <a:font script="Uigh" typeface="Microsoft Uighur"/>
+        <a:font script="Geor" typeface="Sylfaen"/>
+        <a:font script="Armn" typeface="Arial"/>
+        <a:font script="Bugi" typeface="Leelawadee UI"/>
+        <a:font script="Bopo" typeface="Microsoft JhengHei"/>
+        <a:font script="Java" typeface="Javanese Text"/>
+        <a:font script="Lisu" typeface="Segoe UI"/>
+        <a:font script="Mymr" typeface="Myanmar Text"/>
+        <a:font script="Nkoo" typeface="Ebrima"/>
+        <a:font script="Olck" typeface="Nirmala UI"/>
+        <a:font script="Osma" typeface="Ebrima"/>
+        <a:font script="Phag" typeface="Phagspa"/>
+        <a:font script="Syrn" typeface="Estrangelo Edessa"/>
+        <a:font script="Syrj" typeface="Estrangelo Edessa"/>
+        <a:font script="Syre" typeface="Estrangelo Edessa"/>
+        <a:font script="Sora" typeface="Nirmala UI"/>
+        <a:font script="Tale" typeface="Microsoft Tai Le"/>
+        <a:font script="Talu" typeface="Microsoft New Tai Lue"/>
+        <a:font script="Tfng" typeface="Ebrima"/>
+      </a:majorFont>
+      <a:minorFont>
+        <a:latin typeface="Aptos" panose="02110004020202020204"/>
+        <a:ea typeface=""/>
+        <a:cs typeface=""/>
+        <a:font script="Jpan" typeface="游ゴシック"/>
+        <a:font script="Hang" typeface="맑은 고딕"/>
+        <a:font script="Hans" typeface="等线"/>
+        <a:font script="Hant" typeface="新細明體"/>
+        <a:font script="Arab" typeface="Arial"/>
+        <a:font script="Hebr" typeface="Arial"/>
+        <a:font script="Thai" typeface="Cordia New"/>
+        <a:font script="Ethi" typeface="Nyala"/>
+        <a:font script="Beng" typeface="Vrinda"/>
+        <a:font script="Gujr" typeface="Shruti"/>
+        <a:font script="Khmr" typeface="DaunPenh"/>
+        <a:font script="Knda" typeface="Tunga"/>
+        <a:font script="Guru" typeface="Raavi"/>
+        <a:font script="Cans" typeface="Euphemia"/>
+        <a:font script="Cher" typeface="Plantagenet Cherokee"/>
+        <a:font script="Yiii" typeface="Microsoft Yi Baiti"/>
+        <a:font script="Tibt" typeface="Microsoft Himalaya"/>
+        <a:font script="Thaa" typeface="MV Boli"/>
+        <a:font script="Deva" typeface="Mangal"/>
+        <a:font script="Telu" typeface="Gautami"/>
+        <a:font script="Taml" typeface="Latha"/>
+        <a:font script="Syrc" typeface="Estrangelo Edessa"/>
+        <a:font script="Orya" typeface="Kalinga"/>
+        <a:font script="Mlym" typeface="Kartika"/>
+        <a:font script="Laoo" typeface="DokChampa"/>
+        <a:font script="Sinh" typeface="Iskoola Pota"/>
+        <a:font script="Mong" typeface="Mongolian Baiti"/>
+        <a:font script="Viet" typeface="Arial"/>
+        <a:font script="Uigh" typeface="Microsoft Uighur"/>
+        <a:font script="Geor" typeface="Sylfaen"/>
+        <a:font script="Armn" typeface="Arial"/>
+        <a:font script="Bugi" typeface="Leelawadee UI"/>
+        <a:font script="Bopo" typeface="Microsoft JhengHei"/>
+        <a:font script="Java" typeface="Javanese Text"/>
+        <a:font script="Lisu" typeface="Segoe UI"/>
+        <a:font script="Mymr" typeface="Myanmar Text"/>
+        <a:font script="Nkoo" typeface="Ebrima"/>
+        <a:font script="Olck" typeface="Nirmala UI"/>
+        <a:font script="Osma" typeface="Ebrima"/>
+        <a:font script="Phag" typeface="Phagspa"/>
+        <a:font script="Syrn" typeface="Estrangelo Edessa"/>
+        <a:font script="Syrj" typeface="Estrangelo Edessa"/>
+        <a:font script="Syre" typeface="Estrangelo Edessa"/>
+        <a:font script="Sora" typeface="Nirmala UI"/>
+        <a:font script="Tale" typeface="Microsoft Tai Le"/>
+        <a:font script="Talu" typeface="Microsoft New Tai Lue"/>
+        <a:font script="Tfng" typeface="Ebrima"/>
+      </a:minorFont>
+    </a:fontScheme>
+    <a:fmtScheme name="Office">
+      <a:fillStyleLst>
+        <a:solidFill>
+          <a:schemeClr val="phClr"/>
+        </a:solidFill>
+        <a:gradFill rotWithShape="1">
+          <a:gsLst>
+            <a:gs pos="0">
+              <a:schemeClr val="phClr">
+                <a:lumMod val="110000"/>
+                <a:satMod val="105000"/>
+                <a:tint val="67000"/>
+              </a:schemeClr>
+            </a:gs>
+            <a:gs pos="50000">
+              <a:schemeClr val="phClr">
+                <a:lumMod val="105000"/>
+                <a:satMod val="103000"/>
+                <a:tint val="73000"/>
+              </a:schemeClr>
+            </a:gs>
+            <a:gs pos="100000">
+              <a:schemeClr val="phClr">
+                <a:lumMod val="105000"/>
+                <a:satMod val="109000"/>
+                <a:tint val="81000"/>
+              </a:schemeClr>
+            </a:gs>
+          </a:gsLst>
+          <a:lin ang="5400000" scaled="0"/>
+        </a:gradFill>
+        <a:gradFill rotWithShape="1">
+          <a:gsLst>
+            <a:gs pos="0">
+              <a:schemeClr val="phClr">
+                <a:satMod val="103000"/>
+                <a:lumMod val="102000"/>
+                <a:tint val="94000"/>
+              </a:schemeClr>
+            </a:gs>
+            <a:gs pos="50000">
+              <a:schemeClr val="phClr">
+                <a:satMod val="110000"/>
+                <a:lumMod val="100000"/>
+                <a:shade val="100000"/>
+              </a:schemeClr>
+            </a:gs>
+            <a:gs pos="100000">
+              <a:schemeClr val="phClr">
+                <a:lumMod val="99000"/>
+                <a:satMod val="120000"/>
+                <a:shade val="78000"/>
+              </a:schemeClr>
+            </a:gs>
+          </a:gsLst>
+          <a:lin ang="5400000" scaled="0"/>
+        </a:gradFill>
+      </a:fillStyleLst>
+      <a:lnStyleLst>
+        <a:ln w="12700" cap="flat" cmpd="sng" algn="ctr">
+          <a:solidFill>
+            <a:schemeClr val="phClr"/>
+          </a:solidFill>
+          <a:prstDash val="solid"/>
+          <a:miter lim="800000"/>
+        </a:ln>
+        <a:ln w="19050" cap="flat" cmpd="sng" algn="ctr">
+          <a:solidFill>
+            <a:schemeClr val="phClr"/>
+          </a:solidFill>
+          <a:prstDash val="solid"/>
+          <a:miter lim="800000"/>
+        </a:ln>
+        <a:ln w="25400" cap="flat" cmpd="sng" algn="ctr">
+          <a:solidFill>
+            <a:schemeClr val="phClr"/>
+          </a:solidFill>
+          <a:prstDash val="solid"/>
+          <a:miter lim="800000"/>
+        </a:ln>
+      </a:lnStyleLst>
+      <a:effectStyleLst>
+        <a:effectStyle>
+          <a:effectLst/>
+        </a:effectStyle>
+        <a:effectStyle>
+          <a:effectLst/>
+        </a:effectStyle>
+        <a:effectStyle>
+          <a:effectLst>
+            <a:outerShdw blurRad="57150" dist="19050" dir="5400000" algn="ctr" rotWithShape="0">
+              <a:srgbClr val="000000">
+                <a:alpha val="63000"/>
+              </a:srgbClr>
+            </a:outerShdw>
+          </a:effectLst>
+        </a:effectStyle>
+      </a:effectStyleLst>
+      <a:bgFillStyleLst>
+        <a:solidFill>
+          <a:schemeClr val="phClr"/>
+        </a:solidFill>
+        <a:solidFill>
+          <a:schemeClr val="phClr">
+            <a:tint val="95000"/>
+            <a:satMod val="170000"/>
+          </a:schemeClr>
+        </a:solidFill>
+        <a:gradFill rotWithShape="1">
+          <a:gsLst>
+            <a:gs pos="0">
+              <a:schemeClr val="phClr">
+                <a:tint val="93000"/>
+                <a:satMod val="150000"/>
+                <a:shade val="98000"/>
+                <a:lumMod val="102000"/>
+              </a:schemeClr>
+            </a:gs>
+            <a:gs pos="50000">
+              <a:schemeClr val="phClr">
+                <a:tint val="98000"/>
+                <a:satMod val="130000"/>
+                <a:shade val="90000"/>
+                <a:lumMod val="103000"/>
+              </a:schemeClr>
+            </a:gs>
+            <a:gs pos="100000">
+              <a:schemeClr val="phClr">
+                <a:shade val="63000"/>
+                <a:satMod val="120000"/>
+              </a:schemeClr>
+            </a:gs>
+          </a:gsLst>
+          <a:lin ang="5400000" scaled="0"/>
+        </a:gradFill>
+      </a:bgFillStyleLst>
+    </a:fmtScheme>
+  </a:themeElements>
+  <a:objectDefaults>
+    <a:lnDef>
+      <a:spPr/>
+      <a:bodyPr/>
+      <a:lstStyle/>
+      <a:style>
+        <a:lnRef idx="2">
+          <a:schemeClr val="accent1"/>
+        </a:lnRef>
+        <a:fillRef idx="0">
+          <a:schemeClr val="accent1"/>
+        </a:fillRef>
+        <a:effectRef idx="1">
+          <a:schemeClr val="accent1"/>
+        </a:effectRef>
+        <a:fontRef idx="minor">
+          <a:schemeClr val="tx1"/>
+        </a:fontRef>
+      </a:style>
+    </a:lnDef>
+  </a:objectDefaults>
+  <a:extraClrSchemeLst/>
+  <a:extLst>
+    <a:ext uri="{05A4C25C-085E-4340-85A3-A5531E510DB2}">
+      <thm15:themeFamily xmlns:thm15="http://schemas.microsoft.com/office/thememl/2012/main" name="Office Theme" id="{2E142A2C-CD16-42D6-873A-C26D2A0506FA}" vid="{1BDDFF52-6CD6-40A5-AB3C-68EB2F1E4D0A}"/>
+    </a:ext>
+  </a:extLst>
+</a:theme>
 </file>
</xml_diff>